<commit_message>
Update site pages and image assets
</commit_message>
<xml_diff>
--- a/document/terrain.pptx
+++ b/document/terrain.pptx
@@ -6,6 +6,7 @@
   </p:sldMasterIdLst>
   <p:sldIdLst>
     <p:sldId id="256" r:id="rId2"/>
+    <p:sldId id="257" r:id="rId3"/>
   </p:sldIdLst>
   <p:sldSz cx="9144000" cy="6858000" type="screen4x3"/>
   <p:notesSz cx="6858000" cy="9144000"/>
@@ -3176,7 +3177,7 @@
                   <a:srgbClr val="FF0000"/>
                 </a:solidFill>
               </a:rPr>
-              <a:t>30 % off</a:t>
+              <a:t>17.5 % off</a:t>
             </a:r>
             <a:r>
               <a:rPr lang="fr-CA" dirty="0" smtClean="0">
@@ -3198,6 +3199,121 @@
     <p:extLst>
       <p:ext uri="{BB962C8B-B14F-4D97-AF65-F5344CB8AC3E}">
         <p14:creationId xmlns:p14="http://schemas.microsoft.com/office/powerpoint/2010/main" val="4231549562"/>
+      </p:ext>
+    </p:extLst>
+  </p:cSld>
+  <p:clrMapOvr>
+    <a:masterClrMapping/>
+  </p:clrMapOvr>
+  <p:timing>
+    <p:tnLst>
+      <p:par>
+        <p:cTn id="1" dur="indefinite" restart="never" nodeType="tmRoot"/>
+      </p:par>
+    </p:tnLst>
+  </p:timing>
+</p:sld>
+</file>
+
+<file path=ppt/slides/slide2.xml><?xml version="1.0" encoding="utf-8"?>
+<p:sld xmlns:a="http://schemas.openxmlformats.org/drawingml/2006/main" xmlns:r="http://schemas.openxmlformats.org/officeDocument/2006/relationships" xmlns:p="http://schemas.openxmlformats.org/presentationml/2006/main">
+  <p:cSld>
+    <p:spTree>
+      <p:nvGrpSpPr>
+        <p:cNvPr id="1" name=""/>
+        <p:cNvGrpSpPr/>
+        <p:nvPr/>
+      </p:nvGrpSpPr>
+      <p:grpSpPr>
+        <a:xfrm>
+          <a:off x="0" y="0"/>
+          <a:ext cx="0" cy="0"/>
+          <a:chOff x="0" y="0"/>
+          <a:chExt cx="0" cy="0"/>
+        </a:xfrm>
+      </p:grpSpPr>
+      <p:pic>
+        <p:nvPicPr>
+          <p:cNvPr id="2" name="Image 1"/>
+          <p:cNvPicPr>
+            <a:picLocks noChangeAspect="1"/>
+          </p:cNvPicPr>
+          <p:nvPr/>
+        </p:nvPicPr>
+        <p:blipFill>
+          <a:blip r:embed="rId2">
+            <a:extLst>
+              <a:ext uri="{28A0092B-C50C-407E-A947-70E740481C1C}">
+                <a14:useLocalDpi xmlns:a14="http://schemas.microsoft.com/office/drawing/2010/main" val="0"/>
+              </a:ext>
+            </a:extLst>
+          </a:blip>
+          <a:stretch>
+            <a:fillRect/>
+          </a:stretch>
+        </p:blipFill>
+        <p:spPr>
+          <a:xfrm>
+            <a:off x="0" y="1177389"/>
+            <a:ext cx="9144000" cy="4503221"/>
+          </a:xfrm>
+          <a:prstGeom prst="rect">
+            <a:avLst/>
+          </a:prstGeom>
+        </p:spPr>
+      </p:pic>
+      <p:sp>
+        <p:nvSpPr>
+          <p:cNvPr id="3" name="ZoneTexte 2"/>
+          <p:cNvSpPr txBox="1"/>
+          <p:nvPr/>
+        </p:nvSpPr>
+        <p:spPr>
+          <a:xfrm rot="20238446">
+            <a:off x="2911906" y="2872250"/>
+            <a:ext cx="4921540" cy="1754326"/>
+          </a:xfrm>
+          <a:prstGeom prst="rect">
+            <a:avLst/>
+          </a:prstGeom>
+          <a:noFill/>
+        </p:spPr>
+        <p:txBody>
+          <a:bodyPr wrap="none" rtlCol="0">
+            <a:spAutoFit/>
+          </a:bodyPr>
+          <a:lstStyle/>
+          <a:p>
+            <a:r>
+              <a:rPr lang="fr-CA" sz="5400" dirty="0" smtClean="0">
+                <a:solidFill>
+                  <a:srgbClr val="FF0000"/>
+                </a:solidFill>
+              </a:rPr>
+              <a:t>Nouveau prix</a:t>
+            </a:r>
+          </a:p>
+          <a:p>
+            <a:r>
+              <a:rPr lang="fr-CA" sz="5400" dirty="0" smtClean="0">
+                <a:solidFill>
+                  <a:srgbClr val="FF0000"/>
+                </a:solidFill>
+              </a:rPr>
+              <a:t>Rabais de 17.5 %</a:t>
+            </a:r>
+            <a:endParaRPr lang="fr-CA" dirty="0">
+              <a:solidFill>
+                <a:srgbClr val="FF0000"/>
+              </a:solidFill>
+            </a:endParaRPr>
+          </a:p>
+        </p:txBody>
+      </p:sp>
+    </p:spTree>
+    <p:extLst>
+      <p:ext uri="{BB962C8B-B14F-4D97-AF65-F5344CB8AC3E}">
+        <p14:creationId xmlns:p14="http://schemas.microsoft.com/office/powerpoint/2010/main" val="267263724"/>
       </p:ext>
     </p:extLst>
   </p:cSld>

</xml_diff>

<commit_message>
Add updated terrain presentation and spreadsheet
</commit_message>
<xml_diff>
--- a/document/terrain.pptx
+++ b/document/terrain.pptx
@@ -3134,8 +3134,8 @@
         </p:nvSpPr>
         <p:spPr>
           <a:xfrm rot="20238446">
-            <a:off x="3858573" y="2872250"/>
-            <a:ext cx="3028201" cy="1754326"/>
+            <a:off x="3844210" y="2872250"/>
+            <a:ext cx="3056927" cy="1754326"/>
           </a:xfrm>
           <a:prstGeom prst="rect">
             <a:avLst/>
@@ -3154,21 +3154,8 @@
                   <a:srgbClr val="FF0000"/>
                 </a:solidFill>
               </a:rPr>
-              <a:t>New </a:t>
-            </a:r>
-            <a:r>
-              <a:rPr lang="fr-CA" sz="5400" dirty="0" err="1" smtClean="0">
-                <a:solidFill>
-                  <a:srgbClr val="FF0000"/>
-                </a:solidFill>
-              </a:rPr>
-              <a:t>price</a:t>
-            </a:r>
-            <a:endParaRPr lang="fr-CA" sz="5400" dirty="0" smtClean="0">
-              <a:solidFill>
-                <a:srgbClr val="FF0000"/>
-              </a:solidFill>
-            </a:endParaRPr>
+              <a:t>New Price</a:t>
+            </a:r>
           </a:p>
           <a:p>
             <a:r>

</xml_diff>

<commit_message>
Update two modified files
</commit_message>
<xml_diff>
--- a/document/terrain.pptx
+++ b/document/terrain.pptx
@@ -3514,6 +3514,214 @@
           </a:p>
         </p:txBody>
       </p:sp>
+      <p:sp>
+        <p:nvSpPr>
+          <p:cNvPr id="12" name="Rectangle 11">
+            <a:extLst>
+              <a:ext uri="{FF2B5EF4-FFF2-40B4-BE49-F238E27FC236}">
+                <a16:creationId xmlns:a16="http://schemas.microsoft.com/office/drawing/2014/main" id="{CC6BD0A6-6252-E2E7-96AE-D416B7077D8A}"/>
+              </a:ext>
+            </a:extLst>
+          </p:cNvPr>
+          <p:cNvSpPr/>
+          <p:nvPr/>
+        </p:nvSpPr>
+        <p:spPr>
+          <a:xfrm>
+            <a:off x="107504" y="5949280"/>
+            <a:ext cx="504056" cy="288032"/>
+          </a:xfrm>
+          <a:prstGeom prst="rect">
+            <a:avLst/>
+          </a:prstGeom>
+          <a:noFill/>
+          <a:ln>
+            <a:solidFill>
+              <a:srgbClr val="FF0000"/>
+            </a:solidFill>
+          </a:ln>
+        </p:spPr>
+        <p:style>
+          <a:lnRef idx="2">
+            <a:schemeClr val="accent1">
+              <a:shade val="15000"/>
+            </a:schemeClr>
+          </a:lnRef>
+          <a:fillRef idx="1">
+            <a:schemeClr val="accent1"/>
+          </a:fillRef>
+          <a:effectRef idx="0">
+            <a:schemeClr val="accent1"/>
+          </a:effectRef>
+          <a:fontRef idx="minor">
+            <a:schemeClr val="lt1"/>
+          </a:fontRef>
+        </p:style>
+        <p:txBody>
+          <a:bodyPr rtlCol="0" anchor="ctr"/>
+          <a:lstStyle/>
+          <a:p>
+            <a:pPr algn="ctr"/>
+            <a:endParaRPr lang="fr-CA"/>
+          </a:p>
+        </p:txBody>
+      </p:sp>
+      <p:sp>
+        <p:nvSpPr>
+          <p:cNvPr id="13" name="Rectangle 12">
+            <a:extLst>
+              <a:ext uri="{FF2B5EF4-FFF2-40B4-BE49-F238E27FC236}">
+                <a16:creationId xmlns:a16="http://schemas.microsoft.com/office/drawing/2014/main" id="{ECAE79E5-30C7-E094-01E3-983776AF6197}"/>
+              </a:ext>
+            </a:extLst>
+          </p:cNvPr>
+          <p:cNvSpPr/>
+          <p:nvPr/>
+        </p:nvSpPr>
+        <p:spPr>
+          <a:xfrm>
+            <a:off x="2483768" y="2213575"/>
+            <a:ext cx="560825" cy="288032"/>
+          </a:xfrm>
+          <a:prstGeom prst="rect">
+            <a:avLst/>
+          </a:prstGeom>
+          <a:noFill/>
+          <a:ln>
+            <a:solidFill>
+              <a:srgbClr val="FF0000"/>
+            </a:solidFill>
+          </a:ln>
+        </p:spPr>
+        <p:style>
+          <a:lnRef idx="2">
+            <a:schemeClr val="accent1">
+              <a:shade val="15000"/>
+            </a:schemeClr>
+          </a:lnRef>
+          <a:fillRef idx="1">
+            <a:schemeClr val="accent1"/>
+          </a:fillRef>
+          <a:effectRef idx="0">
+            <a:schemeClr val="accent1"/>
+          </a:effectRef>
+          <a:fontRef idx="minor">
+            <a:schemeClr val="lt1"/>
+          </a:fontRef>
+        </p:style>
+        <p:txBody>
+          <a:bodyPr rtlCol="0" anchor="ctr"/>
+          <a:lstStyle/>
+          <a:p>
+            <a:pPr algn="ctr"/>
+            <a:endParaRPr lang="fr-CA"/>
+          </a:p>
+        </p:txBody>
+      </p:sp>
+      <p:sp>
+        <p:nvSpPr>
+          <p:cNvPr id="14" name="Rectangle 13">
+            <a:extLst>
+              <a:ext uri="{FF2B5EF4-FFF2-40B4-BE49-F238E27FC236}">
+                <a16:creationId xmlns:a16="http://schemas.microsoft.com/office/drawing/2014/main" id="{C98DA611-5957-0F0C-121A-E51C76A84698}"/>
+              </a:ext>
+            </a:extLst>
+          </p:cNvPr>
+          <p:cNvSpPr/>
+          <p:nvPr/>
+        </p:nvSpPr>
+        <p:spPr>
+          <a:xfrm>
+            <a:off x="1115616" y="3068960"/>
+            <a:ext cx="504056" cy="288032"/>
+          </a:xfrm>
+          <a:prstGeom prst="rect">
+            <a:avLst/>
+          </a:prstGeom>
+          <a:noFill/>
+          <a:ln>
+            <a:solidFill>
+              <a:srgbClr val="FF0000"/>
+            </a:solidFill>
+          </a:ln>
+        </p:spPr>
+        <p:style>
+          <a:lnRef idx="2">
+            <a:schemeClr val="accent1">
+              <a:shade val="15000"/>
+            </a:schemeClr>
+          </a:lnRef>
+          <a:fillRef idx="1">
+            <a:schemeClr val="accent1"/>
+          </a:fillRef>
+          <a:effectRef idx="0">
+            <a:schemeClr val="accent1"/>
+          </a:effectRef>
+          <a:fontRef idx="minor">
+            <a:schemeClr val="lt1"/>
+          </a:fontRef>
+        </p:style>
+        <p:txBody>
+          <a:bodyPr rtlCol="0" anchor="ctr"/>
+          <a:lstStyle/>
+          <a:p>
+            <a:pPr algn="ctr"/>
+            <a:endParaRPr lang="fr-CA"/>
+          </a:p>
+        </p:txBody>
+      </p:sp>
+      <p:sp>
+        <p:nvSpPr>
+          <p:cNvPr id="15" name="Rectangle 14">
+            <a:extLst>
+              <a:ext uri="{FF2B5EF4-FFF2-40B4-BE49-F238E27FC236}">
+                <a16:creationId xmlns:a16="http://schemas.microsoft.com/office/drawing/2014/main" id="{B1691874-1536-5A47-CE40-41F561AB7DAB}"/>
+              </a:ext>
+            </a:extLst>
+          </p:cNvPr>
+          <p:cNvSpPr/>
+          <p:nvPr/>
+        </p:nvSpPr>
+        <p:spPr>
+          <a:xfrm>
+            <a:off x="6660232" y="2241805"/>
+            <a:ext cx="648072" cy="232024"/>
+          </a:xfrm>
+          <a:prstGeom prst="rect">
+            <a:avLst/>
+          </a:prstGeom>
+          <a:noFill/>
+          <a:ln>
+            <a:solidFill>
+              <a:srgbClr val="FF0000"/>
+            </a:solidFill>
+          </a:ln>
+        </p:spPr>
+        <p:style>
+          <a:lnRef idx="2">
+            <a:schemeClr val="accent1">
+              <a:shade val="15000"/>
+            </a:schemeClr>
+          </a:lnRef>
+          <a:fillRef idx="1">
+            <a:schemeClr val="accent1"/>
+          </a:fillRef>
+          <a:effectRef idx="0">
+            <a:schemeClr val="accent1"/>
+          </a:effectRef>
+          <a:fontRef idx="minor">
+            <a:schemeClr val="lt1"/>
+          </a:fontRef>
+        </p:style>
+        <p:txBody>
+          <a:bodyPr rtlCol="0" anchor="ctr"/>
+          <a:lstStyle/>
+          <a:p>
+            <a:pPr algn="ctr"/>
+            <a:endParaRPr lang="fr-CA"/>
+          </a:p>
+        </p:txBody>
+      </p:sp>
     </p:spTree>
     <p:extLst>
       <p:ext uri="{BB962C8B-B14F-4D97-AF65-F5344CB8AC3E}">

</xml_diff>

<commit_message>
Sync CNAME, terrain.pptx, and index_a.html
</commit_message>
<xml_diff>
--- a/document/terrain.pptx
+++ b/document/terrain.pptx
@@ -7,8 +7,10 @@
   <p:sldIdLst>
     <p:sldId id="256" r:id="rId2"/>
     <p:sldId id="257" r:id="rId3"/>
-    <p:sldId id="258" r:id="rId4"/>
-    <p:sldId id="259" r:id="rId5"/>
+    <p:sldId id="260" r:id="rId4"/>
+    <p:sldId id="261" r:id="rId5"/>
+    <p:sldId id="258" r:id="rId6"/>
+    <p:sldId id="259" r:id="rId7"/>
   </p:sldIdLst>
   <p:sldSz cx="9144000" cy="6858000" type="screen4x3"/>
   <p:notesSz cx="6858000" cy="9144000"/>
@@ -307,7 +309,7 @@
           <a:p>
             <a:fld id="{6AA95906-C7C1-49B4-BB2F-D5ED133CE027}" type="datetimeFigureOut">
               <a:rPr lang="fr-CA" smtClean="0"/>
-              <a:t>2026-05-23</a:t>
+              <a:t>2026-07-23</a:t>
             </a:fld>
             <a:endParaRPr lang="fr-CA"/>
           </a:p>
@@ -477,7 +479,7 @@
           <a:p>
             <a:fld id="{6AA95906-C7C1-49B4-BB2F-D5ED133CE027}" type="datetimeFigureOut">
               <a:rPr lang="fr-CA" smtClean="0"/>
-              <a:t>2026-05-23</a:t>
+              <a:t>2026-07-23</a:t>
             </a:fld>
             <a:endParaRPr lang="fr-CA"/>
           </a:p>
@@ -657,7 +659,7 @@
           <a:p>
             <a:fld id="{6AA95906-C7C1-49B4-BB2F-D5ED133CE027}" type="datetimeFigureOut">
               <a:rPr lang="fr-CA" smtClean="0"/>
-              <a:t>2026-05-23</a:t>
+              <a:t>2026-07-23</a:t>
             </a:fld>
             <a:endParaRPr lang="fr-CA"/>
           </a:p>
@@ -827,7 +829,7 @@
           <a:p>
             <a:fld id="{6AA95906-C7C1-49B4-BB2F-D5ED133CE027}" type="datetimeFigureOut">
               <a:rPr lang="fr-CA" smtClean="0"/>
-              <a:t>2026-05-23</a:t>
+              <a:t>2026-07-23</a:t>
             </a:fld>
             <a:endParaRPr lang="fr-CA"/>
           </a:p>
@@ -1073,7 +1075,7 @@
           <a:p>
             <a:fld id="{6AA95906-C7C1-49B4-BB2F-D5ED133CE027}" type="datetimeFigureOut">
               <a:rPr lang="fr-CA" smtClean="0"/>
-              <a:t>2026-05-23</a:t>
+              <a:t>2026-07-23</a:t>
             </a:fld>
             <a:endParaRPr lang="fr-CA"/>
           </a:p>
@@ -1361,7 +1363,7 @@
           <a:p>
             <a:fld id="{6AA95906-C7C1-49B4-BB2F-D5ED133CE027}" type="datetimeFigureOut">
               <a:rPr lang="fr-CA" smtClean="0"/>
-              <a:t>2026-05-23</a:t>
+              <a:t>2026-07-23</a:t>
             </a:fld>
             <a:endParaRPr lang="fr-CA"/>
           </a:p>
@@ -1783,7 +1785,7 @@
           <a:p>
             <a:fld id="{6AA95906-C7C1-49B4-BB2F-D5ED133CE027}" type="datetimeFigureOut">
               <a:rPr lang="fr-CA" smtClean="0"/>
-              <a:t>2026-05-23</a:t>
+              <a:t>2026-07-23</a:t>
             </a:fld>
             <a:endParaRPr lang="fr-CA"/>
           </a:p>
@@ -1901,7 +1903,7 @@
           <a:p>
             <a:fld id="{6AA95906-C7C1-49B4-BB2F-D5ED133CE027}" type="datetimeFigureOut">
               <a:rPr lang="fr-CA" smtClean="0"/>
-              <a:t>2026-05-23</a:t>
+              <a:t>2026-07-23</a:t>
             </a:fld>
             <a:endParaRPr lang="fr-CA"/>
           </a:p>
@@ -1996,7 +1998,7 @@
           <a:p>
             <a:fld id="{6AA95906-C7C1-49B4-BB2F-D5ED133CE027}" type="datetimeFigureOut">
               <a:rPr lang="fr-CA" smtClean="0"/>
-              <a:t>2026-05-23</a:t>
+              <a:t>2026-07-23</a:t>
             </a:fld>
             <a:endParaRPr lang="fr-CA"/>
           </a:p>
@@ -2273,7 +2275,7 @@
           <a:p>
             <a:fld id="{6AA95906-C7C1-49B4-BB2F-D5ED133CE027}" type="datetimeFigureOut">
               <a:rPr lang="fr-CA" smtClean="0"/>
-              <a:t>2026-05-23</a:t>
+              <a:t>2026-07-23</a:t>
             </a:fld>
             <a:endParaRPr lang="fr-CA"/>
           </a:p>
@@ -2526,7 +2528,7 @@
           <a:p>
             <a:fld id="{6AA95906-C7C1-49B4-BB2F-D5ED133CE027}" type="datetimeFigureOut">
               <a:rPr lang="fr-CA" smtClean="0"/>
-              <a:t>2026-05-23</a:t>
+              <a:t>2026-07-23</a:t>
             </a:fld>
             <a:endParaRPr lang="fr-CA"/>
           </a:p>
@@ -2739,7 +2741,7 @@
           <a:p>
             <a:fld id="{6AA95906-C7C1-49B4-BB2F-D5ED133CE027}" type="datetimeFigureOut">
               <a:rPr lang="fr-CA" smtClean="0"/>
-              <a:t>2026-05-23</a:t>
+              <a:t>2026-07-23</a:t>
             </a:fld>
             <a:endParaRPr lang="fr-CA"/>
           </a:p>
@@ -3319,6 +3321,237 @@
 <file path=ppt/slides/slide3.xml><?xml version="1.0" encoding="utf-8"?>
 <p:sld xmlns:a="http://schemas.openxmlformats.org/drawingml/2006/main" xmlns:r="http://schemas.openxmlformats.org/officeDocument/2006/relationships" xmlns:p="http://schemas.openxmlformats.org/presentationml/2006/main">
   <p:cSld>
+    <p:spTree>
+      <p:nvGrpSpPr>
+        <p:cNvPr id="1" name=""/>
+        <p:cNvGrpSpPr/>
+        <p:nvPr/>
+      </p:nvGrpSpPr>
+      <p:grpSpPr>
+        <a:xfrm>
+          <a:off x="0" y="0"/>
+          <a:ext cx="0" cy="0"/>
+          <a:chOff x="0" y="0"/>
+          <a:chExt cx="0" cy="0"/>
+        </a:xfrm>
+      </p:grpSpPr>
+      <p:pic>
+        <p:nvPicPr>
+          <p:cNvPr id="3" name="Image 2">
+            <a:extLst>
+              <a:ext uri="{FF2B5EF4-FFF2-40B4-BE49-F238E27FC236}">
+                <a16:creationId xmlns:a16="http://schemas.microsoft.com/office/drawing/2014/main" id="{CA8D0DA9-9CAB-AB30-9EB6-C0AED48EC7FA}"/>
+              </a:ext>
+            </a:extLst>
+          </p:cNvPr>
+          <p:cNvPicPr>
+            <a:picLocks noChangeAspect="1"/>
+          </p:cNvPicPr>
+          <p:nvPr/>
+        </p:nvPicPr>
+        <p:blipFill>
+          <a:blip r:embed="rId2">
+            <a:extLst>
+              <a:ext uri="{28A0092B-C50C-407E-A947-70E740481C1C}">
+                <a14:useLocalDpi xmlns:a14="http://schemas.microsoft.com/office/drawing/2010/main" val="0"/>
+              </a:ext>
+            </a:extLst>
+          </a:blip>
+          <a:stretch>
+            <a:fillRect/>
+          </a:stretch>
+        </p:blipFill>
+        <p:spPr>
+          <a:xfrm>
+            <a:off x="0" y="1177389"/>
+            <a:ext cx="9144000" cy="4503221"/>
+          </a:xfrm>
+          <a:prstGeom prst="rect">
+            <a:avLst/>
+          </a:prstGeom>
+        </p:spPr>
+      </p:pic>
+      <p:sp>
+        <p:nvSpPr>
+          <p:cNvPr id="5" name="ZoneTexte 4">
+            <a:extLst>
+              <a:ext uri="{FF2B5EF4-FFF2-40B4-BE49-F238E27FC236}">
+                <a16:creationId xmlns:a16="http://schemas.microsoft.com/office/drawing/2014/main" id="{5526277B-DD30-FFD4-B835-C7BC305ED7AE}"/>
+              </a:ext>
+            </a:extLst>
+          </p:cNvPr>
+          <p:cNvSpPr txBox="1"/>
+          <p:nvPr/>
+        </p:nvSpPr>
+        <p:spPr>
+          <a:xfrm rot="20021038">
+            <a:off x="3272609" y="2522381"/>
+            <a:ext cx="4572000" cy="923330"/>
+          </a:xfrm>
+          <a:prstGeom prst="rect">
+            <a:avLst/>
+          </a:prstGeom>
+          <a:noFill/>
+        </p:spPr>
+        <p:txBody>
+          <a:bodyPr wrap="square">
+            <a:spAutoFit/>
+          </a:bodyPr>
+          <a:lstStyle/>
+          <a:p>
+            <a:r>
+              <a:rPr lang="fr-CA" sz="5400" dirty="0">
+                <a:solidFill>
+                  <a:srgbClr val="FF0000"/>
+                </a:solidFill>
+              </a:rPr>
+              <a:t>Prix réduit</a:t>
+            </a:r>
+          </a:p>
+        </p:txBody>
+      </p:sp>
+    </p:spTree>
+    <p:extLst>
+      <p:ext uri="{BB962C8B-B14F-4D97-AF65-F5344CB8AC3E}">
+        <p14:creationId xmlns:p14="http://schemas.microsoft.com/office/powerpoint/2010/main" val="2667270619"/>
+      </p:ext>
+    </p:extLst>
+  </p:cSld>
+  <p:clrMapOvr>
+    <a:masterClrMapping/>
+  </p:clrMapOvr>
+</p:sld>
+</file>
+
+<file path=ppt/slides/slide4.xml><?xml version="1.0" encoding="utf-8"?>
+<p:sld xmlns:a="http://schemas.openxmlformats.org/drawingml/2006/main" xmlns:r="http://schemas.openxmlformats.org/officeDocument/2006/relationships" xmlns:p="http://schemas.openxmlformats.org/presentationml/2006/main">
+  <p:cSld>
+    <p:spTree>
+      <p:nvGrpSpPr>
+        <p:cNvPr id="1" name=""/>
+        <p:cNvGrpSpPr/>
+        <p:nvPr/>
+      </p:nvGrpSpPr>
+      <p:grpSpPr>
+        <a:xfrm>
+          <a:off x="0" y="0"/>
+          <a:ext cx="0" cy="0"/>
+          <a:chOff x="0" y="0"/>
+          <a:chExt cx="0" cy="0"/>
+        </a:xfrm>
+      </p:grpSpPr>
+      <p:pic>
+        <p:nvPicPr>
+          <p:cNvPr id="3" name="Image 2">
+            <a:extLst>
+              <a:ext uri="{FF2B5EF4-FFF2-40B4-BE49-F238E27FC236}">
+                <a16:creationId xmlns:a16="http://schemas.microsoft.com/office/drawing/2014/main" id="{1220ADCC-BBA2-8DDA-37DE-1E6F084AAAC6}"/>
+              </a:ext>
+            </a:extLst>
+          </p:cNvPr>
+          <p:cNvPicPr>
+            <a:picLocks noChangeAspect="1"/>
+          </p:cNvPicPr>
+          <p:nvPr/>
+        </p:nvPicPr>
+        <p:blipFill>
+          <a:blip r:embed="rId2">
+            <a:extLst>
+              <a:ext uri="{28A0092B-C50C-407E-A947-70E740481C1C}">
+                <a14:useLocalDpi xmlns:a14="http://schemas.microsoft.com/office/drawing/2010/main" val="0"/>
+              </a:ext>
+            </a:extLst>
+          </a:blip>
+          <a:stretch>
+            <a:fillRect/>
+          </a:stretch>
+        </p:blipFill>
+        <p:spPr>
+          <a:xfrm>
+            <a:off x="0" y="1177389"/>
+            <a:ext cx="9144000" cy="4503221"/>
+          </a:xfrm>
+          <a:prstGeom prst="rect">
+            <a:avLst/>
+          </a:prstGeom>
+        </p:spPr>
+      </p:pic>
+      <p:sp>
+        <p:nvSpPr>
+          <p:cNvPr id="5" name="ZoneTexte 4">
+            <a:extLst>
+              <a:ext uri="{FF2B5EF4-FFF2-40B4-BE49-F238E27FC236}">
+                <a16:creationId xmlns:a16="http://schemas.microsoft.com/office/drawing/2014/main" id="{8829AFE6-A8B3-F6F6-6EF3-28B7856C0FF5}"/>
+              </a:ext>
+            </a:extLst>
+          </p:cNvPr>
+          <p:cNvSpPr txBox="1"/>
+          <p:nvPr/>
+        </p:nvSpPr>
+        <p:spPr>
+          <a:xfrm rot="20021038">
+            <a:off x="3272609" y="2522381"/>
+            <a:ext cx="4572000" cy="923330"/>
+          </a:xfrm>
+          <a:prstGeom prst="rect">
+            <a:avLst/>
+          </a:prstGeom>
+          <a:noFill/>
+        </p:spPr>
+        <p:txBody>
+          <a:bodyPr wrap="square">
+            <a:spAutoFit/>
+          </a:bodyPr>
+          <a:lstStyle/>
+          <a:p>
+            <a:r>
+              <a:rPr lang="fr-CA" sz="5400" dirty="0" err="1">
+                <a:solidFill>
+                  <a:srgbClr val="FF0000"/>
+                </a:solidFill>
+              </a:rPr>
+              <a:t>Reduce</a:t>
+            </a:r>
+            <a:r>
+              <a:rPr lang="fr-CA" sz="5400" dirty="0">
+                <a:solidFill>
+                  <a:srgbClr val="FF0000"/>
+                </a:solidFill>
+              </a:rPr>
+              <a:t> </a:t>
+            </a:r>
+            <a:r>
+              <a:rPr lang="fr-CA" sz="5400">
+                <a:solidFill>
+                  <a:srgbClr val="FF0000"/>
+                </a:solidFill>
+              </a:rPr>
+              <a:t>price</a:t>
+            </a:r>
+            <a:endParaRPr lang="fr-CA" sz="5400" dirty="0">
+              <a:solidFill>
+                <a:srgbClr val="FF0000"/>
+              </a:solidFill>
+            </a:endParaRPr>
+          </a:p>
+        </p:txBody>
+      </p:sp>
+    </p:spTree>
+    <p:extLst>
+      <p:ext uri="{BB962C8B-B14F-4D97-AF65-F5344CB8AC3E}">
+        <p14:creationId xmlns:p14="http://schemas.microsoft.com/office/powerpoint/2010/main" val="1788051682"/>
+      </p:ext>
+    </p:extLst>
+  </p:cSld>
+  <p:clrMapOvr>
+    <a:masterClrMapping/>
+  </p:clrMapOvr>
+</p:sld>
+</file>
+
+<file path=ppt/slides/slide5.xml><?xml version="1.0" encoding="utf-8"?>
+<p:sld xmlns:a="http://schemas.openxmlformats.org/drawingml/2006/main" xmlns:r="http://schemas.openxmlformats.org/officeDocument/2006/relationships" xmlns:p="http://schemas.openxmlformats.org/presentationml/2006/main">
+  <p:cSld>
     <p:bg>
       <p:bgPr>
         <a:solidFill>
@@ -3428,7 +3661,7 @@
 </p:sld>
 </file>
 
-<file path=ppt/slides/slide4.xml><?xml version="1.0" encoding="utf-8"?>
+<file path=ppt/slides/slide6.xml><?xml version="1.0" encoding="utf-8"?>
 <p:sld xmlns:a="http://schemas.openxmlformats.org/drawingml/2006/main" xmlns:r="http://schemas.openxmlformats.org/officeDocument/2006/relationships" xmlns:p="http://schemas.openxmlformats.org/presentationml/2006/main">
   <p:cSld>
     <p:spTree>

</xml_diff>

<commit_message>
Update environment pages and styling
</commit_message>
<xml_diff>
--- a/document/terrain.pptx
+++ b/document/terrain.pptx
@@ -309,7 +309,7 @@
           <a:p>
             <a:fld id="{6AA95906-C7C1-49B4-BB2F-D5ED133CE027}" type="datetimeFigureOut">
               <a:rPr lang="fr-CA" smtClean="0"/>
-              <a:t>2026-07-23</a:t>
+              <a:t>2026-07-30</a:t>
             </a:fld>
             <a:endParaRPr lang="fr-CA"/>
           </a:p>
@@ -479,7 +479,7 @@
           <a:p>
             <a:fld id="{6AA95906-C7C1-49B4-BB2F-D5ED133CE027}" type="datetimeFigureOut">
               <a:rPr lang="fr-CA" smtClean="0"/>
-              <a:t>2026-07-23</a:t>
+              <a:t>2026-07-30</a:t>
             </a:fld>
             <a:endParaRPr lang="fr-CA"/>
           </a:p>
@@ -659,7 +659,7 @@
           <a:p>
             <a:fld id="{6AA95906-C7C1-49B4-BB2F-D5ED133CE027}" type="datetimeFigureOut">
               <a:rPr lang="fr-CA" smtClean="0"/>
-              <a:t>2026-07-23</a:t>
+              <a:t>2026-07-30</a:t>
             </a:fld>
             <a:endParaRPr lang="fr-CA"/>
           </a:p>
@@ -829,7 +829,7 @@
           <a:p>
             <a:fld id="{6AA95906-C7C1-49B4-BB2F-D5ED133CE027}" type="datetimeFigureOut">
               <a:rPr lang="fr-CA" smtClean="0"/>
-              <a:t>2026-07-23</a:t>
+              <a:t>2026-07-30</a:t>
             </a:fld>
             <a:endParaRPr lang="fr-CA"/>
           </a:p>
@@ -1075,7 +1075,7 @@
           <a:p>
             <a:fld id="{6AA95906-C7C1-49B4-BB2F-D5ED133CE027}" type="datetimeFigureOut">
               <a:rPr lang="fr-CA" smtClean="0"/>
-              <a:t>2026-07-23</a:t>
+              <a:t>2026-07-30</a:t>
             </a:fld>
             <a:endParaRPr lang="fr-CA"/>
           </a:p>
@@ -1363,7 +1363,7 @@
           <a:p>
             <a:fld id="{6AA95906-C7C1-49B4-BB2F-D5ED133CE027}" type="datetimeFigureOut">
               <a:rPr lang="fr-CA" smtClean="0"/>
-              <a:t>2026-07-23</a:t>
+              <a:t>2026-07-30</a:t>
             </a:fld>
             <a:endParaRPr lang="fr-CA"/>
           </a:p>
@@ -1785,7 +1785,7 @@
           <a:p>
             <a:fld id="{6AA95906-C7C1-49B4-BB2F-D5ED133CE027}" type="datetimeFigureOut">
               <a:rPr lang="fr-CA" smtClean="0"/>
-              <a:t>2026-07-23</a:t>
+              <a:t>2026-07-30</a:t>
             </a:fld>
             <a:endParaRPr lang="fr-CA"/>
           </a:p>
@@ -1903,7 +1903,7 @@
           <a:p>
             <a:fld id="{6AA95906-C7C1-49B4-BB2F-D5ED133CE027}" type="datetimeFigureOut">
               <a:rPr lang="fr-CA" smtClean="0"/>
-              <a:t>2026-07-23</a:t>
+              <a:t>2026-07-30</a:t>
             </a:fld>
             <a:endParaRPr lang="fr-CA"/>
           </a:p>
@@ -1998,7 +1998,7 @@
           <a:p>
             <a:fld id="{6AA95906-C7C1-49B4-BB2F-D5ED133CE027}" type="datetimeFigureOut">
               <a:rPr lang="fr-CA" smtClean="0"/>
-              <a:t>2026-07-23</a:t>
+              <a:t>2026-07-30</a:t>
             </a:fld>
             <a:endParaRPr lang="fr-CA"/>
           </a:p>
@@ -2275,7 +2275,7 @@
           <a:p>
             <a:fld id="{6AA95906-C7C1-49B4-BB2F-D5ED133CE027}" type="datetimeFigureOut">
               <a:rPr lang="fr-CA" smtClean="0"/>
-              <a:t>2026-07-23</a:t>
+              <a:t>2026-07-30</a:t>
             </a:fld>
             <a:endParaRPr lang="fr-CA"/>
           </a:p>
@@ -2528,7 +2528,7 @@
           <a:p>
             <a:fld id="{6AA95906-C7C1-49B4-BB2F-D5ED133CE027}" type="datetimeFigureOut">
               <a:rPr lang="fr-CA" smtClean="0"/>
-              <a:t>2026-07-23</a:t>
+              <a:t>2026-07-30</a:t>
             </a:fld>
             <a:endParaRPr lang="fr-CA"/>
           </a:p>
@@ -2741,7 +2741,7 @@
           <a:p>
             <a:fld id="{6AA95906-C7C1-49B4-BB2F-D5ED133CE027}" type="datetimeFigureOut">
               <a:rPr lang="fr-CA" smtClean="0"/>
-              <a:t>2026-07-23</a:t>
+              <a:t>2026-07-30</a:t>
             </a:fld>
             <a:endParaRPr lang="fr-CA"/>
           </a:p>
@@ -3405,7 +3405,7 @@
                   <a:srgbClr val="FF0000"/>
                 </a:solidFill>
               </a:rPr>
-              <a:t>Prix réduit</a:t>
+              <a:t>Prix révisé</a:t>
             </a:r>
           </a:p>
         </p:txBody>
@@ -3521,7 +3521,7 @@
               <a:t> </a:t>
             </a:r>
             <a:r>
-              <a:rPr lang="fr-CA" sz="5400">
+              <a:rPr lang="fr-CA" sz="5400" dirty="0" err="1">
                 <a:solidFill>
                   <a:srgbClr val="FF0000"/>
                 </a:solidFill>

</xml_diff>